<commit_message>
Add printable flowchart PDF with field readings
One-page A4 landscape flowchart including observed panel state
(63 A, EOCR 3.7 A, no abnormal, heating on) plus decision paths.
Also extends the PowerPoint with field-readings and flowchart slides.

Co-authored-by: riverajk03 <riverajk03@gmail.com>
</commit_message>
<xml_diff>
--- a/No4_ER_Vent_Fan_Start_Run_Stop_Sequence.pptx
+++ b/No4_ER_Vent_Fan_Start_Run_Stop_Sequence.pptx
@@ -14,6 +14,8 @@
     <p:sldId id="262" r:id="rId13"/>
     <p:sldId id="263" r:id="rId14"/>
     <p:sldId id="264" r:id="rId15"/>
+    <p:sldId id="265" r:id="rId16"/>
+    <p:sldId id="266" r:id="rId17"/>
   </p:sldIdLst>
   <p:sldSz cx="12191695" cy="6858000" type="screen4x3"/>
   <p:notesSz cx="6858000" cy="9144000"/>
@@ -3319,6 +3321,2096 @@
                 <a:latin typeface="Calibri"/>
               </a:rPr>
               <a:t>Hyundai Heavy Industries  ·  Shipboard Engine Room Ventilation Fan (Reversible)</a:t>
+            </a:r>
+          </a:p>
+        </p:txBody>
+      </p:sp>
+    </p:spTree>
+  </p:cSld>
+  <p:clrMapOvr>
+    <a:masterClrMapping/>
+  </p:clrMapOvr>
+</p:sld>
+</file>
+
+<file path=ppt/slides/slide10.xml><?xml version="1.0" encoding="utf-8"?>
+<p:sld xmlns:a="http://schemas.openxmlformats.org/drawingml/2006/main" xmlns:p="http://schemas.openxmlformats.org/presentationml/2006/main" xmlns:r="http://schemas.openxmlformats.org/officeDocument/2006/relationships">
+  <p:cSld>
+    <p:spTree>
+      <p:nvGrpSpPr>
+        <p:cNvPr id="1" name=""/>
+        <p:cNvGrpSpPr/>
+        <p:nvPr/>
+      </p:nvGrpSpPr>
+      <p:grpSpPr/>
+      <p:sp>
+        <p:nvSpPr>
+          <p:cNvPr id="2" name="Rectangle 1"/>
+          <p:cNvSpPr/>
+          <p:nvPr/>
+        </p:nvSpPr>
+        <p:spPr>
+          <a:xfrm>
+            <a:off x="0" y="0"/>
+            <a:ext cx="12191695" cy="6858000"/>
+          </a:xfrm>
+          <a:prstGeom prst="rect">
+            <a:avLst/>
+          </a:prstGeom>
+          <a:solidFill>
+            <a:srgbClr val="F4F7FA"/>
+          </a:solidFill>
+          <a:ln>
+            <a:noFill/>
+          </a:ln>
+        </p:spPr>
+        <p:style>
+          <a:lnRef idx="1">
+            <a:schemeClr val="accent1"/>
+          </a:lnRef>
+          <a:fillRef idx="3">
+            <a:schemeClr val="accent1"/>
+          </a:fillRef>
+          <a:effectRef idx="2">
+            <a:schemeClr val="accent1"/>
+          </a:effectRef>
+          <a:fontRef idx="minor">
+            <a:schemeClr val="lt1"/>
+          </a:fontRef>
+        </p:style>
+        <p:txBody>
+          <a:bodyPr rtlCol="0" anchor="ctr"/>
+          <a:lstStyle/>
+          <a:p>
+            <a:pPr algn="ctr"/>
+          </a:p>
+        </p:txBody>
+      </p:sp>
+      <p:sp>
+        <p:nvSpPr>
+          <p:cNvPr id="3" name="Rectangle 2"/>
+          <p:cNvSpPr/>
+          <p:nvPr/>
+        </p:nvSpPr>
+        <p:spPr>
+          <a:xfrm>
+            <a:off x="0" y="0"/>
+            <a:ext cx="12191695" cy="868680"/>
+          </a:xfrm>
+          <a:prstGeom prst="rect">
+            <a:avLst/>
+          </a:prstGeom>
+          <a:solidFill>
+            <a:srgbClr val="0B2C4A"/>
+          </a:solidFill>
+          <a:ln>
+            <a:noFill/>
+          </a:ln>
+        </p:spPr>
+        <p:style>
+          <a:lnRef idx="1">
+            <a:schemeClr val="accent1"/>
+          </a:lnRef>
+          <a:fillRef idx="3">
+            <a:schemeClr val="accent1"/>
+          </a:fillRef>
+          <a:effectRef idx="2">
+            <a:schemeClr val="accent1"/>
+          </a:effectRef>
+          <a:fontRef idx="minor">
+            <a:schemeClr val="lt1"/>
+          </a:fontRef>
+        </p:style>
+        <p:txBody>
+          <a:bodyPr rtlCol="0" anchor="ctr"/>
+          <a:lstStyle/>
+          <a:p>
+            <a:pPr algn="ctr"/>
+          </a:p>
+        </p:txBody>
+      </p:sp>
+      <p:sp>
+        <p:nvSpPr>
+          <p:cNvPr id="4" name="Rectangle 3"/>
+          <p:cNvSpPr/>
+          <p:nvPr/>
+        </p:nvSpPr>
+        <p:spPr>
+          <a:xfrm>
+            <a:off x="0" y="868680"/>
+            <a:ext cx="12191695" cy="73152"/>
+          </a:xfrm>
+          <a:prstGeom prst="rect">
+            <a:avLst/>
+          </a:prstGeom>
+          <a:solidFill>
+            <a:srgbClr val="0E7C7B"/>
+          </a:solidFill>
+          <a:ln>
+            <a:noFill/>
+          </a:ln>
+        </p:spPr>
+        <p:style>
+          <a:lnRef idx="1">
+            <a:schemeClr val="accent1"/>
+          </a:lnRef>
+          <a:fillRef idx="3">
+            <a:schemeClr val="accent1"/>
+          </a:fillRef>
+          <a:effectRef idx="2">
+            <a:schemeClr val="accent1"/>
+          </a:effectRef>
+          <a:fontRef idx="minor">
+            <a:schemeClr val="lt1"/>
+          </a:fontRef>
+        </p:style>
+        <p:txBody>
+          <a:bodyPr rtlCol="0" anchor="ctr"/>
+          <a:lstStyle/>
+          <a:p>
+            <a:pPr algn="ctr"/>
+          </a:p>
+        </p:txBody>
+      </p:sp>
+      <p:sp>
+        <p:nvSpPr>
+          <p:cNvPr id="5" name="TextBox 4"/>
+          <p:cNvSpPr txBox="1"/>
+          <p:nvPr/>
+        </p:nvSpPr>
+        <p:spPr>
+          <a:xfrm>
+            <a:off x="365760" y="164592"/>
+            <a:ext cx="11430000" cy="640080"/>
+          </a:xfrm>
+          <a:prstGeom prst="rect">
+            <a:avLst/>
+          </a:prstGeom>
+          <a:noFill/>
+        </p:spPr>
+        <p:txBody>
+          <a:bodyPr wrap="square">
+            <a:spAutoFit/>
+          </a:bodyPr>
+          <a:lstStyle/>
+          <a:p>
+            <a:r>
+              <a:rPr sz="2400" b="1">
+                <a:solidFill>
+                  <a:srgbClr val="FFFFFF"/>
+                </a:solidFill>
+                <a:latin typeface="Calibri"/>
+              </a:rPr>
+              <a:t>9. Your Field Readings (as found)</a:t>
+            </a:r>
+          </a:p>
+          <a:p>
+            <a:r>
+              <a:rPr sz="1200">
+                <a:solidFill>
+                  <a:srgbClr val="A8C5D8"/>
+                </a:solidFill>
+                <a:latin typeface="Calibri"/>
+              </a:rPr>
+              <a:t>Filled from panel checks during troubleshooting</a:t>
+            </a:r>
+          </a:p>
+        </p:txBody>
+      </p:sp>
+      <p:sp>
+        <p:nvSpPr>
+          <p:cNvPr id="6" name="TextBox 5"/>
+          <p:cNvSpPr txBox="1"/>
+          <p:nvPr/>
+        </p:nvSpPr>
+        <p:spPr>
+          <a:xfrm>
+            <a:off x="365760" y="6537960"/>
+            <a:ext cx="9144000" cy="274320"/>
+          </a:xfrm>
+          <a:prstGeom prst="rect">
+            <a:avLst/>
+          </a:prstGeom>
+          <a:noFill/>
+        </p:spPr>
+        <p:txBody>
+          <a:bodyPr wrap="none">
+            <a:spAutoFit/>
+          </a:bodyPr>
+          <a:lstStyle/>
+          <a:p>
+            <a:r>
+              <a:rPr sz="1000">
+                <a:solidFill>
+                  <a:srgbClr val="5A6A7A"/>
+                </a:solidFill>
+                <a:latin typeface="Calibri"/>
+              </a:rPr>
+              <a:t>NO.4 E/R VENT. FAN (REV)  |  HI-2536-ME-SD1/SD2  |  Field readings included</a:t>
+            </a:r>
+          </a:p>
+        </p:txBody>
+      </p:sp>
+      <p:sp>
+        <p:nvSpPr>
+          <p:cNvPr id="7" name="TextBox 6"/>
+          <p:cNvSpPr txBox="1"/>
+          <p:nvPr/>
+        </p:nvSpPr>
+        <p:spPr>
+          <a:xfrm>
+            <a:off x="10515600" y="6537960"/>
+            <a:ext cx="1371600" cy="274320"/>
+          </a:xfrm>
+          <a:prstGeom prst="rect">
+            <a:avLst/>
+          </a:prstGeom>
+          <a:noFill/>
+        </p:spPr>
+        <p:txBody>
+          <a:bodyPr wrap="none">
+            <a:spAutoFit/>
+          </a:bodyPr>
+          <a:lstStyle/>
+          <a:p>
+            <a:pPr algn="r"/>
+            <a:r>
+              <a:rPr sz="1000">
+                <a:solidFill>
+                  <a:srgbClr val="5A6A7A"/>
+                </a:solidFill>
+                <a:latin typeface="Calibri"/>
+              </a:rPr>
+              <a:t>10 / 11</a:t>
+            </a:r>
+          </a:p>
+        </p:txBody>
+      </p:sp>
+      <p:sp>
+        <p:nvSpPr>
+          <p:cNvPr id="8" name="Rounded Rectangle 7"/>
+          <p:cNvSpPr/>
+          <p:nvPr/>
+        </p:nvSpPr>
+        <p:spPr>
+          <a:xfrm>
+            <a:off x="320040" y="1097280"/>
+            <a:ext cx="11521440" cy="658368"/>
+          </a:xfrm>
+          <a:prstGeom prst="roundRect">
+            <a:avLst>
+              <a:gd name="adj" fmla="val 8000"/>
+            </a:avLst>
+          </a:prstGeom>
+          <a:solidFill>
+            <a:srgbClr val="E8F5E9"/>
+          </a:solidFill>
+          <a:ln w="19050">
+            <a:solidFill>
+              <a:srgbClr val="2E7D32"/>
+            </a:solidFill>
+          </a:ln>
+        </p:spPr>
+        <p:style>
+          <a:lnRef idx="1">
+            <a:schemeClr val="accent1"/>
+          </a:lnRef>
+          <a:fillRef idx="3">
+            <a:schemeClr val="accent1"/>
+          </a:fillRef>
+          <a:effectRef idx="2">
+            <a:schemeClr val="accent1"/>
+          </a:effectRef>
+          <a:fontRef idx="minor">
+            <a:schemeClr val="lt1"/>
+          </a:fontRef>
+        </p:style>
+        <p:txBody>
+          <a:bodyPr rtlCol="0" anchor="ctr"/>
+          <a:lstStyle/>
+          <a:p>
+            <a:pPr algn="ctr"/>
+          </a:p>
+        </p:txBody>
+      </p:sp>
+      <p:sp>
+        <p:nvSpPr>
+          <p:cNvPr id="9" name="TextBox 8"/>
+          <p:cNvSpPr txBox="1"/>
+          <p:nvPr/>
+        </p:nvSpPr>
+        <p:spPr>
+          <a:xfrm>
+            <a:off x="457200" y="1170432"/>
+            <a:ext cx="2926080" cy="502920"/>
+          </a:xfrm>
+          <a:prstGeom prst="rect">
+            <a:avLst/>
+          </a:prstGeom>
+          <a:noFill/>
+        </p:spPr>
+        <p:txBody>
+          <a:bodyPr wrap="square">
+            <a:spAutoFit/>
+          </a:bodyPr>
+          <a:lstStyle/>
+          <a:p>
+            <a:pPr algn="l"/>
+            <a:r>
+              <a:rPr sz="1200" b="1">
+                <a:solidFill>
+                  <a:srgbClr val="2E7D32"/>
+                </a:solidFill>
+                <a:latin typeface="Calibri"/>
+              </a:rPr>
+              <a:t>After-stop lamps</a:t>
+            </a:r>
+          </a:p>
+        </p:txBody>
+      </p:sp>
+      <p:sp>
+        <p:nvSpPr>
+          <p:cNvPr id="10" name="TextBox 9"/>
+          <p:cNvSpPr txBox="1"/>
+          <p:nvPr/>
+        </p:nvSpPr>
+        <p:spPr>
+          <a:xfrm>
+            <a:off x="3383280" y="1170432"/>
+            <a:ext cx="3840480" cy="502920"/>
+          </a:xfrm>
+          <a:prstGeom prst="rect">
+            <a:avLst/>
+          </a:prstGeom>
+          <a:noFill/>
+        </p:spPr>
+        <p:txBody>
+          <a:bodyPr wrap="square">
+            <a:spAutoFit/>
+          </a:bodyPr>
+          <a:lstStyle/>
+          <a:p>
+            <a:pPr algn="l"/>
+            <a:r>
+              <a:rPr sz="1200" b="1">
+                <a:solidFill>
+                  <a:srgbClr val="1A1A1A"/>
+                </a:solidFill>
+                <a:latin typeface="Calibri"/>
+              </a:rPr>
+              <a:t>SOURCE ON · ABNORMAL OFF · INTERVAL OFF · HEATING ON</a:t>
+            </a:r>
+          </a:p>
+        </p:txBody>
+      </p:sp>
+      <p:sp>
+        <p:nvSpPr>
+          <p:cNvPr id="11" name="TextBox 10"/>
+          <p:cNvSpPr txBox="1"/>
+          <p:nvPr/>
+        </p:nvSpPr>
+        <p:spPr>
+          <a:xfrm>
+            <a:off x="7315200" y="1170432"/>
+            <a:ext cx="4297680" cy="502920"/>
+          </a:xfrm>
+          <a:prstGeom prst="rect">
+            <a:avLst/>
+          </a:prstGeom>
+          <a:noFill/>
+        </p:spPr>
+        <p:txBody>
+          <a:bodyPr wrap="square">
+            <a:spAutoFit/>
+          </a:bodyPr>
+          <a:lstStyle/>
+          <a:p>
+            <a:pPr algn="l"/>
+            <a:r>
+              <a:rPr sz="1100" b="0">
+                <a:solidFill>
+                  <a:srgbClr val="1A1A1A"/>
+                </a:solidFill>
+                <a:latin typeface="Calibri"/>
+              </a:rPr>
+              <a:t>Matches NORMAL / command stop state</a:t>
+            </a:r>
+          </a:p>
+        </p:txBody>
+      </p:sp>
+      <p:sp>
+        <p:nvSpPr>
+          <p:cNvPr id="12" name="Rounded Rectangle 11"/>
+          <p:cNvSpPr/>
+          <p:nvPr/>
+        </p:nvSpPr>
+        <p:spPr>
+          <a:xfrm>
+            <a:off x="320040" y="1828800"/>
+            <a:ext cx="11521440" cy="658368"/>
+          </a:xfrm>
+          <a:prstGeom prst="roundRect">
+            <a:avLst>
+              <a:gd name="adj" fmla="val 8000"/>
+            </a:avLst>
+          </a:prstGeom>
+          <a:solidFill>
+            <a:srgbClr val="E3F2FD"/>
+          </a:solidFill>
+          <a:ln w="19050">
+            <a:solidFill>
+              <a:srgbClr val="0E7C7B"/>
+            </a:solidFill>
+          </a:ln>
+        </p:spPr>
+        <p:style>
+          <a:lnRef idx="1">
+            <a:schemeClr val="accent1"/>
+          </a:lnRef>
+          <a:fillRef idx="3">
+            <a:schemeClr val="accent1"/>
+          </a:fillRef>
+          <a:effectRef idx="2">
+            <a:schemeClr val="accent1"/>
+          </a:effectRef>
+          <a:fontRef idx="minor">
+            <a:schemeClr val="lt1"/>
+          </a:fontRef>
+        </p:style>
+        <p:txBody>
+          <a:bodyPr rtlCol="0" anchor="ctr"/>
+          <a:lstStyle/>
+          <a:p>
+            <a:pPr algn="ctr"/>
+          </a:p>
+        </p:txBody>
+      </p:sp>
+      <p:sp>
+        <p:nvSpPr>
+          <p:cNvPr id="13" name="TextBox 12"/>
+          <p:cNvSpPr txBox="1"/>
+          <p:nvPr/>
+        </p:nvSpPr>
+        <p:spPr>
+          <a:xfrm>
+            <a:off x="457200" y="1901952"/>
+            <a:ext cx="2926080" cy="502920"/>
+          </a:xfrm>
+          <a:prstGeom prst="rect">
+            <a:avLst/>
+          </a:prstGeom>
+          <a:noFill/>
+        </p:spPr>
+        <p:txBody>
+          <a:bodyPr wrap="square">
+            <a:spAutoFit/>
+          </a:bodyPr>
+          <a:lstStyle/>
+          <a:p>
+            <a:pPr algn="l"/>
+            <a:r>
+              <a:rPr sz="1200" b="1">
+                <a:solidFill>
+                  <a:srgbClr val="0E7C7B"/>
+                </a:solidFill>
+                <a:latin typeface="Calibri"/>
+              </a:rPr>
+              <a:t>Door ammeter (running)</a:t>
+            </a:r>
+          </a:p>
+        </p:txBody>
+      </p:sp>
+      <p:sp>
+        <p:nvSpPr>
+          <p:cNvPr id="14" name="TextBox 13"/>
+          <p:cNvSpPr txBox="1"/>
+          <p:nvPr/>
+        </p:nvSpPr>
+        <p:spPr>
+          <a:xfrm>
+            <a:off x="3383280" y="1901952"/>
+            <a:ext cx="3840480" cy="502920"/>
+          </a:xfrm>
+          <a:prstGeom prst="rect">
+            <a:avLst/>
+          </a:prstGeom>
+          <a:noFill/>
+        </p:spPr>
+        <p:txBody>
+          <a:bodyPr wrap="square">
+            <a:spAutoFit/>
+          </a:bodyPr>
+          <a:lstStyle/>
+          <a:p>
+            <a:pPr algn="l"/>
+            <a:r>
+              <a:rPr sz="1200" b="1">
+                <a:solidFill>
+                  <a:srgbClr val="1A1A1A"/>
+                </a:solidFill>
+                <a:latin typeface="Calibri"/>
+              </a:rPr>
+              <a:t>~ 63 A  (FLA 65.4 A)</a:t>
+            </a:r>
+          </a:p>
+        </p:txBody>
+      </p:sp>
+      <p:sp>
+        <p:nvSpPr>
+          <p:cNvPr id="15" name="TextBox 14"/>
+          <p:cNvSpPr txBox="1"/>
+          <p:nvPr/>
+        </p:nvSpPr>
+        <p:spPr>
+          <a:xfrm>
+            <a:off x="7315200" y="1901952"/>
+            <a:ext cx="4297680" cy="502920"/>
+          </a:xfrm>
+          <a:prstGeom prst="rect">
+            <a:avLst/>
+          </a:prstGeom>
+          <a:noFill/>
+        </p:spPr>
+        <p:txBody>
+          <a:bodyPr wrap="square">
+            <a:spAutoFit/>
+          </a:bodyPr>
+          <a:lstStyle/>
+          <a:p>
+            <a:pPr algn="l"/>
+            <a:r>
+              <a:rPr sz="1100" b="0">
+                <a:solidFill>
+                  <a:srgbClr val="1A1A1A"/>
+                </a:solidFill>
+                <a:latin typeface="Calibri"/>
+              </a:rPr>
+              <a:t>Under FLA — looks normal</a:t>
+            </a:r>
+          </a:p>
+        </p:txBody>
+      </p:sp>
+      <p:sp>
+        <p:nvSpPr>
+          <p:cNvPr id="16" name="Rounded Rectangle 15"/>
+          <p:cNvSpPr/>
+          <p:nvPr/>
+        </p:nvSpPr>
+        <p:spPr>
+          <a:xfrm>
+            <a:off x="320040" y="2560320"/>
+            <a:ext cx="11521440" cy="658368"/>
+          </a:xfrm>
+          <a:prstGeom prst="roundRect">
+            <a:avLst>
+              <a:gd name="adj" fmla="val 8000"/>
+            </a:avLst>
+          </a:prstGeom>
+          <a:solidFill>
+            <a:srgbClr val="FDE8D8"/>
+          </a:solidFill>
+          <a:ln w="19050">
+            <a:solidFill>
+              <a:srgbClr val="C45C26"/>
+            </a:solidFill>
+          </a:ln>
+        </p:spPr>
+        <p:style>
+          <a:lnRef idx="1">
+            <a:schemeClr val="accent1"/>
+          </a:lnRef>
+          <a:fillRef idx="3">
+            <a:schemeClr val="accent1"/>
+          </a:fillRef>
+          <a:effectRef idx="2">
+            <a:schemeClr val="accent1"/>
+          </a:effectRef>
+          <a:fontRef idx="minor">
+            <a:schemeClr val="lt1"/>
+          </a:fontRef>
+        </p:style>
+        <p:txBody>
+          <a:bodyPr rtlCol="0" anchor="ctr"/>
+          <a:lstStyle/>
+          <a:p>
+            <a:pPr algn="ctr"/>
+          </a:p>
+        </p:txBody>
+      </p:sp>
+      <p:sp>
+        <p:nvSpPr>
+          <p:cNvPr id="17" name="TextBox 16"/>
+          <p:cNvSpPr txBox="1"/>
+          <p:nvPr/>
+        </p:nvSpPr>
+        <p:spPr>
+          <a:xfrm>
+            <a:off x="457200" y="2633472"/>
+            <a:ext cx="2926080" cy="502920"/>
+          </a:xfrm>
+          <a:prstGeom prst="rect">
+            <a:avLst/>
+          </a:prstGeom>
+          <a:noFill/>
+        </p:spPr>
+        <p:txBody>
+          <a:bodyPr wrap="square">
+            <a:spAutoFit/>
+          </a:bodyPr>
+          <a:lstStyle/>
+          <a:p>
+            <a:pPr algn="l"/>
+            <a:r>
+              <a:rPr sz="1200" b="1">
+                <a:solidFill>
+                  <a:srgbClr val="C45C26"/>
+                </a:solidFill>
+                <a:latin typeface="Calibri"/>
+              </a:rPr>
+              <a:t>EOCR measured</a:t>
+            </a:r>
+          </a:p>
+        </p:txBody>
+      </p:sp>
+      <p:sp>
+        <p:nvSpPr>
+          <p:cNvPr id="18" name="TextBox 17"/>
+          <p:cNvSpPr txBox="1"/>
+          <p:nvPr/>
+        </p:nvSpPr>
+        <p:spPr>
+          <a:xfrm>
+            <a:off x="3383280" y="2633472"/>
+            <a:ext cx="3840480" cy="502920"/>
+          </a:xfrm>
+          <a:prstGeom prst="rect">
+            <a:avLst/>
+          </a:prstGeom>
+          <a:noFill/>
+        </p:spPr>
+        <p:txBody>
+          <a:bodyPr wrap="square">
+            <a:spAutoFit/>
+          </a:bodyPr>
+          <a:lstStyle/>
+          <a:p>
+            <a:pPr algn="l"/>
+            <a:r>
+              <a:rPr sz="1200" b="1">
+                <a:solidFill>
+                  <a:srgbClr val="1A1A1A"/>
+                </a:solidFill>
+                <a:latin typeface="Calibri"/>
+              </a:rPr>
+              <a:t>3.7 A secondary</a:t>
+            </a:r>
+          </a:p>
+        </p:txBody>
+      </p:sp>
+      <p:sp>
+        <p:nvSpPr>
+          <p:cNvPr id="19" name="TextBox 18"/>
+          <p:cNvSpPr txBox="1"/>
+          <p:nvPr/>
+        </p:nvSpPr>
+        <p:spPr>
+          <a:xfrm>
+            <a:off x="7315200" y="2633472"/>
+            <a:ext cx="4297680" cy="502920"/>
+          </a:xfrm>
+          <a:prstGeom prst="rect">
+            <a:avLst/>
+          </a:prstGeom>
+          <a:noFill/>
+        </p:spPr>
+        <p:txBody>
+          <a:bodyPr wrap="square">
+            <a:spAutoFit/>
+          </a:bodyPr>
+          <a:lstStyle/>
+          <a:p>
+            <a:pPr algn="l"/>
+            <a:r>
+              <a:rPr sz="1100" b="0">
+                <a:solidFill>
+                  <a:srgbClr val="1A1A1A"/>
+                </a:solidFill>
+                <a:latin typeface="Calibri"/>
+              </a:rPr>
+              <a:t>Above SET’G 3.27 A — INV may trip in minutes</a:t>
+            </a:r>
+          </a:p>
+        </p:txBody>
+      </p:sp>
+      <p:sp>
+        <p:nvSpPr>
+          <p:cNvPr id="20" name="Rounded Rectangle 19"/>
+          <p:cNvSpPr/>
+          <p:nvPr/>
+        </p:nvSpPr>
+        <p:spPr>
+          <a:xfrm>
+            <a:off x="320040" y="3291840"/>
+            <a:ext cx="11521440" cy="658368"/>
+          </a:xfrm>
+          <a:prstGeom prst="roundRect">
+            <a:avLst>
+              <a:gd name="adj" fmla="val 8000"/>
+            </a:avLst>
+          </a:prstGeom>
+          <a:solidFill>
+            <a:srgbClr val="FDE8D8"/>
+          </a:solidFill>
+          <a:ln w="19050">
+            <a:solidFill>
+              <a:srgbClr val="C45C26"/>
+            </a:solidFill>
+          </a:ln>
+        </p:spPr>
+        <p:style>
+          <a:lnRef idx="1">
+            <a:schemeClr val="accent1"/>
+          </a:lnRef>
+          <a:fillRef idx="3">
+            <a:schemeClr val="accent1"/>
+          </a:fillRef>
+          <a:effectRef idx="2">
+            <a:schemeClr val="accent1"/>
+          </a:effectRef>
+          <a:fontRef idx="minor">
+            <a:schemeClr val="lt1"/>
+          </a:fontRef>
+        </p:style>
+        <p:txBody>
+          <a:bodyPr rtlCol="0" anchor="ctr"/>
+          <a:lstStyle/>
+          <a:p>
+            <a:pPr algn="ctr"/>
+          </a:p>
+        </p:txBody>
+      </p:sp>
+      <p:sp>
+        <p:nvSpPr>
+          <p:cNvPr id="21" name="TextBox 20"/>
+          <p:cNvSpPr txBox="1"/>
+          <p:nvPr/>
+        </p:nvSpPr>
+        <p:spPr>
+          <a:xfrm>
+            <a:off x="457200" y="3364992"/>
+            <a:ext cx="2926080" cy="502920"/>
+          </a:xfrm>
+          <a:prstGeom prst="rect">
+            <a:avLst/>
+          </a:prstGeom>
+          <a:noFill/>
+        </p:spPr>
+        <p:txBody>
+          <a:bodyPr wrap="square">
+            <a:spAutoFit/>
+          </a:bodyPr>
+          <a:lstStyle/>
+          <a:p>
+            <a:pPr algn="l"/>
+            <a:r>
+              <a:rPr sz="1200" b="1">
+                <a:solidFill>
+                  <a:srgbClr val="C45C26"/>
+                </a:solidFill>
+                <a:latin typeface="Calibri"/>
+              </a:rPr>
+              <a:t>EOCR setting (drawing)</a:t>
+            </a:r>
+          </a:p>
+        </p:txBody>
+      </p:sp>
+      <p:sp>
+        <p:nvSpPr>
+          <p:cNvPr id="22" name="TextBox 21"/>
+          <p:cNvSpPr txBox="1"/>
+          <p:nvPr/>
+        </p:nvSpPr>
+        <p:spPr>
+          <a:xfrm>
+            <a:off x="3383280" y="3364992"/>
+            <a:ext cx="3840480" cy="502920"/>
+          </a:xfrm>
+          <a:prstGeom prst="rect">
+            <a:avLst/>
+          </a:prstGeom>
+          <a:noFill/>
+        </p:spPr>
+        <p:txBody>
+          <a:bodyPr wrap="square">
+            <a:spAutoFit/>
+          </a:bodyPr>
+          <a:lstStyle/>
+          <a:p>
+            <a:pPr algn="l"/>
+            <a:r>
+              <a:rPr sz="1200" b="1">
+                <a:solidFill>
+                  <a:srgbClr val="1A1A1A"/>
+                </a:solidFill>
+                <a:latin typeface="Calibri"/>
+              </a:rPr>
+              <a:t>SET’G 3.27 A · CHA INV · D-TIME 6 s</a:t>
+            </a:r>
+          </a:p>
+        </p:txBody>
+      </p:sp>
+      <p:sp>
+        <p:nvSpPr>
+          <p:cNvPr id="23" name="TextBox 22"/>
+          <p:cNvSpPr txBox="1"/>
+          <p:nvPr/>
+        </p:nvSpPr>
+        <p:spPr>
+          <a:xfrm>
+            <a:off x="7315200" y="3364992"/>
+            <a:ext cx="4297680" cy="502920"/>
+          </a:xfrm>
+          <a:prstGeom prst="rect">
+            <a:avLst/>
+          </a:prstGeom>
+          <a:noFill/>
+        </p:spPr>
+        <p:txBody>
+          <a:bodyPr wrap="square">
+            <a:spAutoFit/>
+          </a:bodyPr>
+          <a:lstStyle/>
+          <a:p>
+            <a:pPr algn="l"/>
+            <a:r>
+              <a:rPr sz="1100" b="0">
+                <a:solidFill>
+                  <a:srgbClr val="1A1A1A"/>
+                </a:solidFill>
+                <a:latin typeface="Calibri"/>
+              </a:rPr>
+              <a:t>Expected secondary at FLA ≈ 3.27 A (CT 100/5)</a:t>
+            </a:r>
+          </a:p>
+        </p:txBody>
+      </p:sp>
+      <p:sp>
+        <p:nvSpPr>
+          <p:cNvPr id="24" name="Rounded Rectangle 23"/>
+          <p:cNvSpPr/>
+          <p:nvPr/>
+        </p:nvSpPr>
+        <p:spPr>
+          <a:xfrm>
+            <a:off x="320040" y="4023360"/>
+            <a:ext cx="11521440" cy="658368"/>
+          </a:xfrm>
+          <a:prstGeom prst="roundRect">
+            <a:avLst>
+              <a:gd name="adj" fmla="val 8000"/>
+            </a:avLst>
+          </a:prstGeom>
+          <a:solidFill>
+            <a:srgbClr val="FFEBEE"/>
+          </a:solidFill>
+          <a:ln w="19050">
+            <a:solidFill>
+              <a:srgbClr val="B71C1C"/>
+            </a:solidFill>
+          </a:ln>
+        </p:spPr>
+        <p:style>
+          <a:lnRef idx="1">
+            <a:schemeClr val="accent1"/>
+          </a:lnRef>
+          <a:fillRef idx="3">
+            <a:schemeClr val="accent1"/>
+          </a:fillRef>
+          <a:effectRef idx="2">
+            <a:schemeClr val="accent1"/>
+          </a:effectRef>
+          <a:fontRef idx="minor">
+            <a:schemeClr val="lt1"/>
+          </a:fontRef>
+        </p:style>
+        <p:txBody>
+          <a:bodyPr rtlCol="0" anchor="ctr"/>
+          <a:lstStyle/>
+          <a:p>
+            <a:pPr algn="ctr"/>
+          </a:p>
+        </p:txBody>
+      </p:sp>
+      <p:sp>
+        <p:nvSpPr>
+          <p:cNvPr id="25" name="TextBox 24"/>
+          <p:cNvSpPr txBox="1"/>
+          <p:nvPr/>
+        </p:nvSpPr>
+        <p:spPr>
+          <a:xfrm>
+            <a:off x="457200" y="4096512"/>
+            <a:ext cx="2926080" cy="502920"/>
+          </a:xfrm>
+          <a:prstGeom prst="rect">
+            <a:avLst/>
+          </a:prstGeom>
+          <a:noFill/>
+        </p:spPr>
+        <p:txBody>
+          <a:bodyPr wrap="square">
+            <a:spAutoFit/>
+          </a:bodyPr>
+          <a:lstStyle/>
+          <a:p>
+            <a:pPr algn="l"/>
+            <a:r>
+              <a:rPr sz="1200" b="1">
+                <a:solidFill>
+                  <a:srgbClr val="B71C1C"/>
+                </a:solidFill>
+                <a:latin typeface="Calibri"/>
+              </a:rPr>
+              <a:t>88F contactor</a:t>
+            </a:r>
+          </a:p>
+        </p:txBody>
+      </p:sp>
+      <p:sp>
+        <p:nvSpPr>
+          <p:cNvPr id="26" name="TextBox 25"/>
+          <p:cNvSpPr txBox="1"/>
+          <p:nvPr/>
+        </p:nvSpPr>
+        <p:spPr>
+          <a:xfrm>
+            <a:off x="3383280" y="4096512"/>
+            <a:ext cx="3840480" cy="502920"/>
+          </a:xfrm>
+          <a:prstGeom prst="rect">
+            <a:avLst/>
+          </a:prstGeom>
+          <a:noFill/>
+        </p:spPr>
+        <p:txBody>
+          <a:bodyPr wrap="square">
+            <a:spAutoFit/>
+          </a:bodyPr>
+          <a:lstStyle/>
+          <a:p>
+            <a:pPr algn="l"/>
+            <a:r>
+              <a:rPr sz="1200" b="1">
+                <a:solidFill>
+                  <a:srgbClr val="1A1A1A"/>
+                </a:solidFill>
+                <a:latin typeface="Calibri"/>
+              </a:rPr>
+              <a:t>Already renewed</a:t>
+            </a:r>
+          </a:p>
+        </p:txBody>
+      </p:sp>
+      <p:sp>
+        <p:nvSpPr>
+          <p:cNvPr id="27" name="TextBox 26"/>
+          <p:cNvSpPr txBox="1"/>
+          <p:nvPr/>
+        </p:nvSpPr>
+        <p:spPr>
+          <a:xfrm>
+            <a:off x="7315200" y="4096512"/>
+            <a:ext cx="4297680" cy="502920"/>
+          </a:xfrm>
+          <a:prstGeom prst="rect">
+            <a:avLst/>
+          </a:prstGeom>
+          <a:noFill/>
+        </p:spPr>
+        <p:txBody>
+          <a:bodyPr wrap="square">
+            <a:spAutoFit/>
+          </a:bodyPr>
+          <a:lstStyle/>
+          <a:p>
+            <a:pPr algn="l"/>
+            <a:r>
+              <a:rPr sz="1100" b="0">
+                <a:solidFill>
+                  <a:srgbClr val="1A1A1A"/>
+                </a:solidFill>
+                <a:latin typeface="Calibri"/>
+              </a:rPr>
+              <a:t>Did not cure delayed stop</a:t>
+            </a:r>
+          </a:p>
+        </p:txBody>
+      </p:sp>
+      <p:sp>
+        <p:nvSpPr>
+          <p:cNvPr id="28" name="Rounded Rectangle 27"/>
+          <p:cNvSpPr/>
+          <p:nvPr/>
+        </p:nvSpPr>
+        <p:spPr>
+          <a:xfrm>
+            <a:off x="320040" y="4754880"/>
+            <a:ext cx="11521440" cy="658368"/>
+          </a:xfrm>
+          <a:prstGeom prst="roundRect">
+            <a:avLst>
+              <a:gd name="adj" fmla="val 8000"/>
+            </a:avLst>
+          </a:prstGeom>
+          <a:solidFill>
+            <a:srgbClr val="E8F5E9"/>
+          </a:solidFill>
+          <a:ln w="19050">
+            <a:solidFill>
+              <a:srgbClr val="2E7D32"/>
+            </a:solidFill>
+          </a:ln>
+        </p:spPr>
+        <p:style>
+          <a:lnRef idx="1">
+            <a:schemeClr val="accent1"/>
+          </a:lnRef>
+          <a:fillRef idx="3">
+            <a:schemeClr val="accent1"/>
+          </a:fillRef>
+          <a:effectRef idx="2">
+            <a:schemeClr val="accent1"/>
+          </a:effectRef>
+          <a:fontRef idx="minor">
+            <a:schemeClr val="lt1"/>
+          </a:fontRef>
+        </p:style>
+        <p:txBody>
+          <a:bodyPr rtlCol="0" anchor="ctr"/>
+          <a:lstStyle/>
+          <a:p>
+            <a:pPr algn="ctr"/>
+          </a:p>
+        </p:txBody>
+      </p:sp>
+      <p:sp>
+        <p:nvSpPr>
+          <p:cNvPr id="29" name="TextBox 28"/>
+          <p:cNvSpPr txBox="1"/>
+          <p:nvPr/>
+        </p:nvSpPr>
+        <p:spPr>
+          <a:xfrm>
+            <a:off x="457200" y="4828032"/>
+            <a:ext cx="2926080" cy="502920"/>
+          </a:xfrm>
+          <a:prstGeom prst="rect">
+            <a:avLst/>
+          </a:prstGeom>
+          <a:noFill/>
+        </p:spPr>
+        <p:txBody>
+          <a:bodyPr wrap="square">
+            <a:spAutoFit/>
+          </a:bodyPr>
+          <a:lstStyle/>
+          <a:p>
+            <a:pPr algn="l"/>
+            <a:r>
+              <a:rPr sz="1200" b="1">
+                <a:solidFill>
+                  <a:srgbClr val="2E7D32"/>
+                </a:solidFill>
+                <a:latin typeface="Calibri"/>
+              </a:rPr>
+              <a:t>Lamp test</a:t>
+            </a:r>
+          </a:p>
+        </p:txBody>
+      </p:sp>
+      <p:sp>
+        <p:nvSpPr>
+          <p:cNvPr id="30" name="TextBox 29"/>
+          <p:cNvSpPr txBox="1"/>
+          <p:nvPr/>
+        </p:nvSpPr>
+        <p:spPr>
+          <a:xfrm>
+            <a:off x="3383280" y="4828032"/>
+            <a:ext cx="3840480" cy="502920"/>
+          </a:xfrm>
+          <a:prstGeom prst="rect">
+            <a:avLst/>
+          </a:prstGeom>
+          <a:noFill/>
+        </p:spPr>
+        <p:txBody>
+          <a:bodyPr wrap="square">
+            <a:spAutoFit/>
+          </a:bodyPr>
+          <a:lstStyle/>
+          <a:p>
+            <a:pPr algn="l"/>
+            <a:r>
+              <a:rPr sz="1200" b="1">
+                <a:solidFill>
+                  <a:srgbClr val="1A1A1A"/>
+                </a:solidFill>
+                <a:latin typeface="Calibri"/>
+              </a:rPr>
+              <a:t>All indicators OK</a:t>
+            </a:r>
+          </a:p>
+        </p:txBody>
+      </p:sp>
+      <p:sp>
+        <p:nvSpPr>
+          <p:cNvPr id="31" name="TextBox 30"/>
+          <p:cNvSpPr txBox="1"/>
+          <p:nvPr/>
+        </p:nvSpPr>
+        <p:spPr>
+          <a:xfrm>
+            <a:off x="7315200" y="4828032"/>
+            <a:ext cx="4297680" cy="502920"/>
+          </a:xfrm>
+          <a:prstGeom prst="rect">
+            <a:avLst/>
+          </a:prstGeom>
+          <a:noFill/>
+        </p:spPr>
+        <p:txBody>
+          <a:bodyPr wrap="square">
+            <a:spAutoFit/>
+          </a:bodyPr>
+          <a:lstStyle/>
+          <a:p>
+            <a:pPr algn="l"/>
+            <a:r>
+              <a:rPr sz="1100" b="0">
+                <a:solidFill>
+                  <a:srgbClr val="1A1A1A"/>
+                </a:solidFill>
+                <a:latin typeface="Calibri"/>
+              </a:rPr>
+              <a:t>ABNORMAL lamp is good — so OFF means truly no alarm</a:t>
+            </a:r>
+          </a:p>
+        </p:txBody>
+      </p:sp>
+      <p:sp>
+        <p:nvSpPr>
+          <p:cNvPr id="32" name="Rounded Rectangle 31"/>
+          <p:cNvSpPr/>
+          <p:nvPr/>
+        </p:nvSpPr>
+        <p:spPr>
+          <a:xfrm>
+            <a:off x="320040" y="5486400"/>
+            <a:ext cx="11521440" cy="658368"/>
+          </a:xfrm>
+          <a:prstGeom prst="roundRect">
+            <a:avLst>
+              <a:gd name="adj" fmla="val 8000"/>
+            </a:avLst>
+          </a:prstGeom>
+          <a:solidFill>
+            <a:srgbClr val="FDE8D8"/>
+          </a:solidFill>
+          <a:ln w="19050">
+            <a:solidFill>
+              <a:srgbClr val="E65100"/>
+            </a:solidFill>
+          </a:ln>
+        </p:spPr>
+        <p:style>
+          <a:lnRef idx="1">
+            <a:schemeClr val="accent1"/>
+          </a:lnRef>
+          <a:fillRef idx="3">
+            <a:schemeClr val="accent1"/>
+          </a:fillRef>
+          <a:effectRef idx="2">
+            <a:schemeClr val="accent1"/>
+          </a:effectRef>
+          <a:fontRef idx="minor">
+            <a:schemeClr val="lt1"/>
+          </a:fontRef>
+        </p:style>
+        <p:txBody>
+          <a:bodyPr rtlCol="0" anchor="ctr"/>
+          <a:lstStyle/>
+          <a:p>
+            <a:pPr algn="ctr"/>
+          </a:p>
+        </p:txBody>
+      </p:sp>
+      <p:sp>
+        <p:nvSpPr>
+          <p:cNvPr id="33" name="TextBox 32"/>
+          <p:cNvSpPr txBox="1"/>
+          <p:nvPr/>
+        </p:nvSpPr>
+        <p:spPr>
+          <a:xfrm>
+            <a:off x="457200" y="5559552"/>
+            <a:ext cx="2926080" cy="502920"/>
+          </a:xfrm>
+          <a:prstGeom prst="rect">
+            <a:avLst/>
+          </a:prstGeom>
+          <a:noFill/>
+        </p:spPr>
+        <p:txBody>
+          <a:bodyPr wrap="square">
+            <a:spAutoFit/>
+          </a:bodyPr>
+          <a:lstStyle/>
+          <a:p>
+            <a:pPr algn="l"/>
+            <a:r>
+              <a:rPr sz="1200" b="1">
+                <a:solidFill>
+                  <a:srgbClr val="E65100"/>
+                </a:solidFill>
+                <a:latin typeface="Calibri"/>
+              </a:rPr>
+              <a:t>Conflict to resolve</a:t>
+            </a:r>
+          </a:p>
+        </p:txBody>
+      </p:sp>
+      <p:sp>
+        <p:nvSpPr>
+          <p:cNvPr id="34" name="TextBox 33"/>
+          <p:cNvSpPr txBox="1"/>
+          <p:nvPr/>
+        </p:nvSpPr>
+        <p:spPr>
+          <a:xfrm>
+            <a:off x="3383280" y="5559552"/>
+            <a:ext cx="3840480" cy="502920"/>
+          </a:xfrm>
+          <a:prstGeom prst="rect">
+            <a:avLst/>
+          </a:prstGeom>
+          <a:noFill/>
+        </p:spPr>
+        <p:txBody>
+          <a:bodyPr wrap="square">
+            <a:spAutoFit/>
+          </a:bodyPr>
+          <a:lstStyle/>
+          <a:p>
+            <a:pPr algn="l"/>
+            <a:r>
+              <a:rPr sz="1200" b="1">
+                <a:solidFill>
+                  <a:srgbClr val="1A1A1A"/>
+                </a:solidFill>
+                <a:latin typeface="Calibri"/>
+              </a:rPr>
+              <a:t>Door ~63 A vs EOCR 3.7 A</a:t>
+            </a:r>
+          </a:p>
+        </p:txBody>
+      </p:sp>
+      <p:sp>
+        <p:nvSpPr>
+          <p:cNvPr id="35" name="TextBox 34"/>
+          <p:cNvSpPr txBox="1"/>
+          <p:nvPr/>
+        </p:nvSpPr>
+        <p:spPr>
+          <a:xfrm>
+            <a:off x="7315200" y="5559552"/>
+            <a:ext cx="4297680" cy="502920"/>
+          </a:xfrm>
+          <a:prstGeom prst="rect">
+            <a:avLst/>
+          </a:prstGeom>
+          <a:noFill/>
+        </p:spPr>
+        <p:txBody>
+          <a:bodyPr wrap="square">
+            <a:spAutoFit/>
+          </a:bodyPr>
+          <a:lstStyle/>
+          <a:p>
+            <a:pPr algn="l"/>
+            <a:r>
+              <a:rPr sz="1100" b="0">
+                <a:solidFill>
+                  <a:srgbClr val="1A1A1A"/>
+                </a:solidFill>
+                <a:latin typeface="Calibri"/>
+              </a:rPr>
+              <a:t>Use clamp meter on all 3 phases to decide real vs false</a:t>
+            </a:r>
+          </a:p>
+        </p:txBody>
+      </p:sp>
+    </p:spTree>
+  </p:cSld>
+  <p:clrMapOvr>
+    <a:masterClrMapping/>
+  </p:clrMapOvr>
+</p:sld>
+</file>
+
+<file path=ppt/slides/slide11.xml><?xml version="1.0" encoding="utf-8"?>
+<p:sld xmlns:a="http://schemas.openxmlformats.org/drawingml/2006/main" xmlns:p="http://schemas.openxmlformats.org/presentationml/2006/main" xmlns:r="http://schemas.openxmlformats.org/officeDocument/2006/relationships">
+  <p:cSld>
+    <p:spTree>
+      <p:nvGrpSpPr>
+        <p:cNvPr id="1" name=""/>
+        <p:cNvGrpSpPr/>
+        <p:nvPr/>
+      </p:nvGrpSpPr>
+      <p:grpSpPr/>
+      <p:sp>
+        <p:nvSpPr>
+          <p:cNvPr id="2" name="Rectangle 1"/>
+          <p:cNvSpPr/>
+          <p:nvPr/>
+        </p:nvSpPr>
+        <p:spPr>
+          <a:xfrm>
+            <a:off x="0" y="0"/>
+            <a:ext cx="12191695" cy="6858000"/>
+          </a:xfrm>
+          <a:prstGeom prst="rect">
+            <a:avLst/>
+          </a:prstGeom>
+          <a:solidFill>
+            <a:srgbClr val="F4F7FA"/>
+          </a:solidFill>
+          <a:ln>
+            <a:noFill/>
+          </a:ln>
+        </p:spPr>
+        <p:style>
+          <a:lnRef idx="1">
+            <a:schemeClr val="accent1"/>
+          </a:lnRef>
+          <a:fillRef idx="3">
+            <a:schemeClr val="accent1"/>
+          </a:fillRef>
+          <a:effectRef idx="2">
+            <a:schemeClr val="accent1"/>
+          </a:effectRef>
+          <a:fontRef idx="minor">
+            <a:schemeClr val="lt1"/>
+          </a:fontRef>
+        </p:style>
+        <p:txBody>
+          <a:bodyPr rtlCol="0" anchor="ctr"/>
+          <a:lstStyle/>
+          <a:p>
+            <a:pPr algn="ctr"/>
+          </a:p>
+        </p:txBody>
+      </p:sp>
+      <p:sp>
+        <p:nvSpPr>
+          <p:cNvPr id="3" name="Rectangle 2"/>
+          <p:cNvSpPr/>
+          <p:nvPr/>
+        </p:nvSpPr>
+        <p:spPr>
+          <a:xfrm>
+            <a:off x="0" y="0"/>
+            <a:ext cx="12191695" cy="868680"/>
+          </a:xfrm>
+          <a:prstGeom prst="rect">
+            <a:avLst/>
+          </a:prstGeom>
+          <a:solidFill>
+            <a:srgbClr val="0B2C4A"/>
+          </a:solidFill>
+          <a:ln>
+            <a:noFill/>
+          </a:ln>
+        </p:spPr>
+        <p:style>
+          <a:lnRef idx="1">
+            <a:schemeClr val="accent1"/>
+          </a:lnRef>
+          <a:fillRef idx="3">
+            <a:schemeClr val="accent1"/>
+          </a:fillRef>
+          <a:effectRef idx="2">
+            <a:schemeClr val="accent1"/>
+          </a:effectRef>
+          <a:fontRef idx="minor">
+            <a:schemeClr val="lt1"/>
+          </a:fontRef>
+        </p:style>
+        <p:txBody>
+          <a:bodyPr rtlCol="0" anchor="ctr"/>
+          <a:lstStyle/>
+          <a:p>
+            <a:pPr algn="ctr"/>
+          </a:p>
+        </p:txBody>
+      </p:sp>
+      <p:sp>
+        <p:nvSpPr>
+          <p:cNvPr id="4" name="Rectangle 3"/>
+          <p:cNvSpPr/>
+          <p:nvPr/>
+        </p:nvSpPr>
+        <p:spPr>
+          <a:xfrm>
+            <a:off x="0" y="868680"/>
+            <a:ext cx="12191695" cy="73152"/>
+          </a:xfrm>
+          <a:prstGeom prst="rect">
+            <a:avLst/>
+          </a:prstGeom>
+          <a:solidFill>
+            <a:srgbClr val="0E7C7B"/>
+          </a:solidFill>
+          <a:ln>
+            <a:noFill/>
+          </a:ln>
+        </p:spPr>
+        <p:style>
+          <a:lnRef idx="1">
+            <a:schemeClr val="accent1"/>
+          </a:lnRef>
+          <a:fillRef idx="3">
+            <a:schemeClr val="accent1"/>
+          </a:fillRef>
+          <a:effectRef idx="2">
+            <a:schemeClr val="accent1"/>
+          </a:effectRef>
+          <a:fontRef idx="minor">
+            <a:schemeClr val="lt1"/>
+          </a:fontRef>
+        </p:style>
+        <p:txBody>
+          <a:bodyPr rtlCol="0" anchor="ctr"/>
+          <a:lstStyle/>
+          <a:p>
+            <a:pPr algn="ctr"/>
+          </a:p>
+        </p:txBody>
+      </p:sp>
+      <p:sp>
+        <p:nvSpPr>
+          <p:cNvPr id="5" name="TextBox 4"/>
+          <p:cNvSpPr txBox="1"/>
+          <p:nvPr/>
+        </p:nvSpPr>
+        <p:spPr>
+          <a:xfrm>
+            <a:off x="365760" y="164592"/>
+            <a:ext cx="11430000" cy="640080"/>
+          </a:xfrm>
+          <a:prstGeom prst="rect">
+            <a:avLst/>
+          </a:prstGeom>
+          <a:noFill/>
+        </p:spPr>
+        <p:txBody>
+          <a:bodyPr wrap="square">
+            <a:spAutoFit/>
+          </a:bodyPr>
+          <a:lstStyle/>
+          <a:p>
+            <a:r>
+              <a:rPr sz="2400" b="1">
+                <a:solidFill>
+                  <a:srgbClr val="FFFFFF"/>
+                </a:solidFill>
+                <a:latin typeface="Calibri"/>
+              </a:rPr>
+              <a:t>10. One-Page Flowchart (print companion)</a:t>
+            </a:r>
+          </a:p>
+          <a:p>
+            <a:r>
+              <a:rPr sz="1200">
+                <a:solidFill>
+                  <a:srgbClr val="A8C5D8"/>
+                </a:solidFill>
+                <a:latin typeface="Calibri"/>
+              </a:rPr>
+              <a:t>Same content as the A4 landscape PDF — keep beside the panel</a:t>
+            </a:r>
+          </a:p>
+        </p:txBody>
+      </p:sp>
+      <p:sp>
+        <p:nvSpPr>
+          <p:cNvPr id="6" name="TextBox 5"/>
+          <p:cNvSpPr txBox="1"/>
+          <p:nvPr/>
+        </p:nvSpPr>
+        <p:spPr>
+          <a:xfrm>
+            <a:off x="365760" y="6537960"/>
+            <a:ext cx="9144000" cy="274320"/>
+          </a:xfrm>
+          <a:prstGeom prst="rect">
+            <a:avLst/>
+          </a:prstGeom>
+          <a:noFill/>
+        </p:spPr>
+        <p:txBody>
+          <a:bodyPr wrap="none">
+            <a:spAutoFit/>
+          </a:bodyPr>
+          <a:lstStyle/>
+          <a:p>
+            <a:r>
+              <a:rPr sz="1000">
+                <a:solidFill>
+                  <a:srgbClr val="5A6A7A"/>
+                </a:solidFill>
+                <a:latin typeface="Calibri"/>
+              </a:rPr>
+              <a:t>NO.4 E/R VENT. FAN (REV)  |  HI-2536-ME-SD1/SD2  |  Field readings included</a:t>
+            </a:r>
+          </a:p>
+        </p:txBody>
+      </p:sp>
+      <p:sp>
+        <p:nvSpPr>
+          <p:cNvPr id="7" name="TextBox 6"/>
+          <p:cNvSpPr txBox="1"/>
+          <p:nvPr/>
+        </p:nvSpPr>
+        <p:spPr>
+          <a:xfrm>
+            <a:off x="10515600" y="6537960"/>
+            <a:ext cx="1371600" cy="274320"/>
+          </a:xfrm>
+          <a:prstGeom prst="rect">
+            <a:avLst/>
+          </a:prstGeom>
+          <a:noFill/>
+        </p:spPr>
+        <p:txBody>
+          <a:bodyPr wrap="none">
+            <a:spAutoFit/>
+          </a:bodyPr>
+          <a:lstStyle/>
+          <a:p>
+            <a:pPr algn="r"/>
+            <a:r>
+              <a:rPr sz="1000">
+                <a:solidFill>
+                  <a:srgbClr val="5A6A7A"/>
+                </a:solidFill>
+                <a:latin typeface="Calibri"/>
+              </a:rPr>
+              <a:t>11 / 11</a:t>
+            </a:r>
+          </a:p>
+        </p:txBody>
+      </p:sp>
+      <p:sp>
+        <p:nvSpPr>
+          <p:cNvPr id="8" name="Rounded Rectangle 7"/>
+          <p:cNvSpPr/>
+          <p:nvPr/>
+        </p:nvSpPr>
+        <p:spPr>
+          <a:xfrm>
+            <a:off x="320040" y="1143000"/>
+            <a:ext cx="3749039" cy="5120640"/>
+          </a:xfrm>
+          <a:prstGeom prst="roundRect">
+            <a:avLst>
+              <a:gd name="adj" fmla="val 8000"/>
+            </a:avLst>
+          </a:prstGeom>
+          <a:solidFill>
+            <a:srgbClr val="D4EFEE"/>
+          </a:solidFill>
+          <a:ln w="19050">
+            <a:solidFill>
+              <a:srgbClr val="0E7C7B"/>
+            </a:solidFill>
+          </a:ln>
+        </p:spPr>
+        <p:style>
+          <a:lnRef idx="1">
+            <a:schemeClr val="accent1"/>
+          </a:lnRef>
+          <a:fillRef idx="3">
+            <a:schemeClr val="accent1"/>
+          </a:fillRef>
+          <a:effectRef idx="2">
+            <a:schemeClr val="accent1"/>
+          </a:effectRef>
+          <a:fontRef idx="minor">
+            <a:schemeClr val="lt1"/>
+          </a:fontRef>
+        </p:style>
+        <p:txBody>
+          <a:bodyPr rtlCol="0" anchor="ctr"/>
+          <a:lstStyle/>
+          <a:p>
+            <a:pPr algn="ctr"/>
+          </a:p>
+        </p:txBody>
+      </p:sp>
+      <p:sp>
+        <p:nvSpPr>
+          <p:cNvPr id="9" name="Rounded Rectangle 8"/>
+          <p:cNvSpPr/>
+          <p:nvPr/>
+        </p:nvSpPr>
+        <p:spPr>
+          <a:xfrm>
+            <a:off x="502920" y="1325880"/>
+            <a:ext cx="3383280" cy="457200"/>
+          </a:xfrm>
+          <a:prstGeom prst="roundRect">
+            <a:avLst>
+              <a:gd name="adj" fmla="val 15000"/>
+            </a:avLst>
+          </a:prstGeom>
+          <a:solidFill>
+            <a:srgbClr val="0E7C7B"/>
+          </a:solidFill>
+          <a:ln>
+            <a:noFill/>
+          </a:ln>
+        </p:spPr>
+        <p:style>
+          <a:lnRef idx="1">
+            <a:schemeClr val="accent1"/>
+          </a:lnRef>
+          <a:fillRef idx="3">
+            <a:schemeClr val="accent1"/>
+          </a:fillRef>
+          <a:effectRef idx="2">
+            <a:schemeClr val="accent1"/>
+          </a:effectRef>
+          <a:fontRef idx="minor">
+            <a:schemeClr val="lt1"/>
+          </a:fontRef>
+        </p:style>
+        <p:txBody>
+          <a:bodyPr rtlCol="0" anchor="ctr"/>
+          <a:lstStyle/>
+          <a:p>
+            <a:pPr algn="ctr"/>
+          </a:p>
+        </p:txBody>
+      </p:sp>
+      <p:sp>
+        <p:nvSpPr>
+          <p:cNvPr id="10" name="TextBox 9"/>
+          <p:cNvSpPr txBox="1"/>
+          <p:nvPr/>
+        </p:nvSpPr>
+        <p:spPr>
+          <a:xfrm>
+            <a:off x="502920" y="1389888"/>
+            <a:ext cx="3383280" cy="365760"/>
+          </a:xfrm>
+          <a:prstGeom prst="rect">
+            <a:avLst/>
+          </a:prstGeom>
+          <a:noFill/>
+        </p:spPr>
+        <p:txBody>
+          <a:bodyPr wrap="square">
+            <a:spAutoFit/>
+          </a:bodyPr>
+          <a:lstStyle/>
+          <a:p>
+            <a:pPr algn="ctr"/>
+            <a:r>
+              <a:rPr sz="1400" b="1">
+                <a:solidFill>
+                  <a:srgbClr val="FFFFFF"/>
+                </a:solidFill>
+                <a:latin typeface="Calibri"/>
+              </a:rPr>
+              <a:t>START → RUN</a:t>
+            </a:r>
+          </a:p>
+        </p:txBody>
+      </p:sp>
+      <p:sp>
+        <p:nvSpPr>
+          <p:cNvPr id="11" name="TextBox 10"/>
+          <p:cNvSpPr txBox="1"/>
+          <p:nvPr/>
+        </p:nvSpPr>
+        <p:spPr>
+          <a:xfrm>
+            <a:off x="548640" y="1965960"/>
+            <a:ext cx="3291840" cy="4023360"/>
+          </a:xfrm>
+          <a:prstGeom prst="rect">
+            <a:avLst/>
+          </a:prstGeom>
+          <a:noFill/>
+        </p:spPr>
+        <p:txBody>
+          <a:bodyPr wrap="square">
+            <a:spAutoFit/>
+          </a:bodyPr>
+          <a:lstStyle/>
+          <a:p>
+            <a:pPr algn="l"/>
+            <a:r>
+              <a:rPr sz="1300" b="0">
+                <a:solidFill>
+                  <a:srgbClr val="1A1A1A"/>
+                </a:solidFill>
+                <a:latin typeface="Calibri"/>
+              </a:rPr>
+              <a:t>1. Pre-start OK (52, SOURCE, no abnormal)
+2. Press SUPPLY or EXHAUST
+3. Heater OFF (88SH open)
+4. Reduced V start (6-1/6-2 + ATr)
+5. Timer 19 ≈ 30 s transition
+6. Full voltage via 88F / 88R
+7. 4FX / 4RX feedback to SMC
+8. Monitor A + EOCR + lamps</a:t>
+            </a:r>
+          </a:p>
+        </p:txBody>
+      </p:sp>
+      <p:sp>
+        <p:nvSpPr>
+          <p:cNvPr id="12" name="Rounded Rectangle 11"/>
+          <p:cNvSpPr/>
+          <p:nvPr/>
+        </p:nvSpPr>
+        <p:spPr>
+          <a:xfrm>
+            <a:off x="4251959" y="1143000"/>
+            <a:ext cx="3749039" cy="5120640"/>
+          </a:xfrm>
+          <a:prstGeom prst="roundRect">
+            <a:avLst>
+              <a:gd name="adj" fmla="val 8000"/>
+            </a:avLst>
+          </a:prstGeom>
+          <a:solidFill>
+            <a:srgbClr val="E8F5E9"/>
+          </a:solidFill>
+          <a:ln w="19050">
+            <a:solidFill>
+              <a:srgbClr val="2E7D32"/>
+            </a:solidFill>
+          </a:ln>
+        </p:spPr>
+        <p:style>
+          <a:lnRef idx="1">
+            <a:schemeClr val="accent1"/>
+          </a:lnRef>
+          <a:fillRef idx="3">
+            <a:schemeClr val="accent1"/>
+          </a:fillRef>
+          <a:effectRef idx="2">
+            <a:schemeClr val="accent1"/>
+          </a:effectRef>
+          <a:fontRef idx="minor">
+            <a:schemeClr val="lt1"/>
+          </a:fontRef>
+        </p:style>
+        <p:txBody>
+          <a:bodyPr rtlCol="0" anchor="ctr"/>
+          <a:lstStyle/>
+          <a:p>
+            <a:pPr algn="ctr"/>
+          </a:p>
+        </p:txBody>
+      </p:sp>
+      <p:sp>
+        <p:nvSpPr>
+          <p:cNvPr id="13" name="Rounded Rectangle 12"/>
+          <p:cNvSpPr/>
+          <p:nvPr/>
+        </p:nvSpPr>
+        <p:spPr>
+          <a:xfrm>
+            <a:off x="4434839" y="1325880"/>
+            <a:ext cx="3383280" cy="457200"/>
+          </a:xfrm>
+          <a:prstGeom prst="roundRect">
+            <a:avLst>
+              <a:gd name="adj" fmla="val 15000"/>
+            </a:avLst>
+          </a:prstGeom>
+          <a:solidFill>
+            <a:srgbClr val="2E7D32"/>
+          </a:solidFill>
+          <a:ln>
+            <a:noFill/>
+          </a:ln>
+        </p:spPr>
+        <p:style>
+          <a:lnRef idx="1">
+            <a:schemeClr val="accent1"/>
+          </a:lnRef>
+          <a:fillRef idx="3">
+            <a:schemeClr val="accent1"/>
+          </a:fillRef>
+          <a:effectRef idx="2">
+            <a:schemeClr val="accent1"/>
+          </a:effectRef>
+          <a:fontRef idx="minor">
+            <a:schemeClr val="lt1"/>
+          </a:fontRef>
+        </p:style>
+        <p:txBody>
+          <a:bodyPr rtlCol="0" anchor="ctr"/>
+          <a:lstStyle/>
+          <a:p>
+            <a:pPr algn="ctr"/>
+          </a:p>
+        </p:txBody>
+      </p:sp>
+      <p:sp>
+        <p:nvSpPr>
+          <p:cNvPr id="14" name="TextBox 13"/>
+          <p:cNvSpPr txBox="1"/>
+          <p:nvPr/>
+        </p:nvSpPr>
+        <p:spPr>
+          <a:xfrm>
+            <a:off x="4434839" y="1389888"/>
+            <a:ext cx="3383280" cy="365760"/>
+          </a:xfrm>
+          <a:prstGeom prst="rect">
+            <a:avLst/>
+          </a:prstGeom>
+          <a:noFill/>
+        </p:spPr>
+        <p:txBody>
+          <a:bodyPr wrap="square">
+            <a:spAutoFit/>
+          </a:bodyPr>
+          <a:lstStyle/>
+          <a:p>
+            <a:pPr algn="ctr"/>
+            <a:r>
+              <a:rPr sz="1400" b="1">
+                <a:solidFill>
+                  <a:srgbClr val="FFFFFF"/>
+                </a:solidFill>
+                <a:latin typeface="Calibri"/>
+              </a:rPr>
+              <a:t>NORMAL STOP</a:t>
+            </a:r>
+          </a:p>
+        </p:txBody>
+      </p:sp>
+      <p:sp>
+        <p:nvSpPr>
+          <p:cNvPr id="15" name="TextBox 14"/>
+          <p:cNvSpPr txBox="1"/>
+          <p:nvPr/>
+        </p:nvSpPr>
+        <p:spPr>
+          <a:xfrm>
+            <a:off x="4480559" y="1965960"/>
+            <a:ext cx="3291840" cy="4023360"/>
+          </a:xfrm>
+          <a:prstGeom prst="rect">
+            <a:avLst/>
+          </a:prstGeom>
+          <a:noFill/>
+        </p:spPr>
+        <p:txBody>
+          <a:bodyPr wrap="square">
+            <a:spAutoFit/>
+          </a:bodyPr>
+          <a:lstStyle/>
+          <a:p>
+            <a:pPr algn="l"/>
+            <a:r>
+              <a:rPr sz="1300" b="0">
+                <a:solidFill>
+                  <a:srgbClr val="1A1A1A"/>
+                </a:solidFill>
+                <a:latin typeface="Calibri"/>
+              </a:rPr>
+              <a:t>STOP / command drop
+4F/4R release
+88F/88R open → Amp 0
+HEATING ON (if heater ON)
+ABNORMAL stays OFF
+Your after-stop state matched this
+→ check STOP / SMC / remote</a:t>
+            </a:r>
+          </a:p>
+        </p:txBody>
+      </p:sp>
+      <p:sp>
+        <p:nvSpPr>
+          <p:cNvPr id="16" name="Rounded Rectangle 15"/>
+          <p:cNvSpPr/>
+          <p:nvPr/>
+        </p:nvSpPr>
+        <p:spPr>
+          <a:xfrm>
+            <a:off x="8183879" y="1143000"/>
+            <a:ext cx="3749039" cy="5120640"/>
+          </a:xfrm>
+          <a:prstGeom prst="roundRect">
+            <a:avLst>
+              <a:gd name="adj" fmla="val 8000"/>
+            </a:avLst>
+          </a:prstGeom>
+          <a:solidFill>
+            <a:srgbClr val="FDE8D8"/>
+          </a:solidFill>
+          <a:ln w="19050">
+            <a:solidFill>
+              <a:srgbClr val="C45C26"/>
+            </a:solidFill>
+          </a:ln>
+        </p:spPr>
+        <p:style>
+          <a:lnRef idx="1">
+            <a:schemeClr val="accent1"/>
+          </a:lnRef>
+          <a:fillRef idx="3">
+            <a:schemeClr val="accent1"/>
+          </a:fillRef>
+          <a:effectRef idx="2">
+            <a:schemeClr val="accent1"/>
+          </a:effectRef>
+          <a:fontRef idx="minor">
+            <a:schemeClr val="lt1"/>
+          </a:fontRef>
+        </p:style>
+        <p:txBody>
+          <a:bodyPr rtlCol="0" anchor="ctr"/>
+          <a:lstStyle/>
+          <a:p>
+            <a:pPr algn="ctr"/>
+          </a:p>
+        </p:txBody>
+      </p:sp>
+      <p:sp>
+        <p:nvSpPr>
+          <p:cNvPr id="17" name="Rounded Rectangle 16"/>
+          <p:cNvSpPr/>
+          <p:nvPr/>
+        </p:nvSpPr>
+        <p:spPr>
+          <a:xfrm>
+            <a:off x="8366759" y="1325880"/>
+            <a:ext cx="3383280" cy="457200"/>
+          </a:xfrm>
+          <a:prstGeom prst="roundRect">
+            <a:avLst>
+              <a:gd name="adj" fmla="val 15000"/>
+            </a:avLst>
+          </a:prstGeom>
+          <a:solidFill>
+            <a:srgbClr val="C45C26"/>
+          </a:solidFill>
+          <a:ln>
+            <a:noFill/>
+          </a:ln>
+        </p:spPr>
+        <p:style>
+          <a:lnRef idx="1">
+            <a:schemeClr val="accent1"/>
+          </a:lnRef>
+          <a:fillRef idx="3">
+            <a:schemeClr val="accent1"/>
+          </a:fillRef>
+          <a:effectRef idx="2">
+            <a:schemeClr val="accent1"/>
+          </a:effectRef>
+          <a:fontRef idx="minor">
+            <a:schemeClr val="lt1"/>
+          </a:fontRef>
+        </p:style>
+        <p:txBody>
+          <a:bodyPr rtlCol="0" anchor="ctr"/>
+          <a:lstStyle/>
+          <a:p>
+            <a:pPr algn="ctr"/>
+          </a:p>
+        </p:txBody>
+      </p:sp>
+      <p:sp>
+        <p:nvSpPr>
+          <p:cNvPr id="18" name="TextBox 17"/>
+          <p:cNvSpPr txBox="1"/>
+          <p:nvPr/>
+        </p:nvSpPr>
+        <p:spPr>
+          <a:xfrm>
+            <a:off x="8366759" y="1389888"/>
+            <a:ext cx="3383280" cy="365760"/>
+          </a:xfrm>
+          <a:prstGeom prst="rect">
+            <a:avLst/>
+          </a:prstGeom>
+          <a:noFill/>
+        </p:spPr>
+        <p:txBody>
+          <a:bodyPr wrap="square">
+            <a:spAutoFit/>
+          </a:bodyPr>
+          <a:lstStyle/>
+          <a:p>
+            <a:pPr algn="ctr"/>
+            <a:r>
+              <a:rPr sz="1400" b="1">
+                <a:solidFill>
+                  <a:srgbClr val="FFFFFF"/>
+                </a:solidFill>
+                <a:latin typeface="Calibri"/>
+              </a:rPr>
+              <a:t>NEXT ACTION</a:t>
+            </a:r>
+          </a:p>
+        </p:txBody>
+      </p:sp>
+      <p:sp>
+        <p:nvSpPr>
+          <p:cNvPr id="19" name="TextBox 18"/>
+          <p:cNvSpPr txBox="1"/>
+          <p:nvPr/>
+        </p:nvSpPr>
+        <p:spPr>
+          <a:xfrm>
+            <a:off x="8412479" y="1965960"/>
+            <a:ext cx="3291840" cy="4023360"/>
+          </a:xfrm>
+          <a:prstGeom prst="rect">
+            <a:avLst/>
+          </a:prstGeom>
+          <a:noFill/>
+        </p:spPr>
+        <p:txBody>
+          <a:bodyPr wrap="square">
+            <a:spAutoFit/>
+          </a:bodyPr>
+          <a:lstStyle/>
+          <a:p>
+            <a:pPr algn="l"/>
+            <a:r>
+              <a:rPr sz="1300" b="0">
+                <a:solidFill>
+                  <a:srgbClr val="1A1A1A"/>
+                </a:solidFill>
+                <a:latin typeface="Calibri"/>
+              </a:rPr>
+              <a:t>Clamp all 3 phases while running
+Compare to door A and EOCR 3.7
+If clamp ≈ 63 A: EOCR/CT suspect
+If clamp high: real overload
+Watch stop: SUPPLY lamp first?
+Retest in LOCAL only</a:t>
             </a:r>
           </a:p>
         </p:txBody>

</xml_diff>

<commit_message>
Add highlighted wire-path diagrams from start
Power and control path diagrams showing energize order from SUPPLY
start through reduced-voltage, full-voltage run, feedback, and EOCR
trip path. PDF + PNGs; appended to the sequence PowerPoint.

Co-authored-by: riverajk03 <riverajk03@gmail.com>
</commit_message>
<xml_diff>
--- a/No4_ER_Vent_Fan_Start_Run_Stop_Sequence.pptx
+++ b/No4_ER_Vent_Fan_Start_Run_Stop_Sequence.pptx
@@ -16,6 +16,8 @@
     <p:sldId id="264" r:id="rId15"/>
     <p:sldId id="265" r:id="rId16"/>
     <p:sldId id="266" r:id="rId17"/>
+    <p:sldId id="267" r:id="rId18"/>
+    <p:sldId id="268" r:id="rId19"/>
   </p:sldIdLst>
   <p:sldSz cx="12191695" cy="6858000" type="screen4x3"/>
   <p:notesSz cx="6858000" cy="9144000"/>
@@ -5415,6 +5417,176 @@
           </a:p>
         </p:txBody>
       </p:sp>
+    </p:spTree>
+  </p:cSld>
+  <p:clrMapOvr>
+    <a:masterClrMapping/>
+  </p:clrMapOvr>
+</p:sld>
+</file>
+
+<file path=ppt/slides/slide12.xml><?xml version="1.0" encoding="utf-8"?>
+<p:sld xmlns:a="http://schemas.openxmlformats.org/drawingml/2006/main" xmlns:p="http://schemas.openxmlformats.org/presentationml/2006/main" xmlns:r="http://schemas.openxmlformats.org/officeDocument/2006/relationships">
+  <p:cSld>
+    <p:spTree>
+      <p:nvGrpSpPr>
+        <p:cNvPr id="1" name=""/>
+        <p:cNvGrpSpPr/>
+        <p:nvPr/>
+      </p:nvGrpSpPr>
+      <p:grpSpPr/>
+      <p:sp>
+        <p:nvSpPr>
+          <p:cNvPr id="2" name="Rectangle 1"/>
+          <p:cNvSpPr/>
+          <p:nvPr/>
+        </p:nvSpPr>
+        <p:spPr>
+          <a:xfrm>
+            <a:off x="0" y="0"/>
+            <a:ext cx="12191695" cy="6858000"/>
+          </a:xfrm>
+          <a:prstGeom prst="rect">
+            <a:avLst/>
+          </a:prstGeom>
+          <a:solidFill>
+            <a:srgbClr val="F4F7FA"/>
+          </a:solidFill>
+          <a:ln>
+            <a:noFill/>
+          </a:ln>
+        </p:spPr>
+        <p:style>
+          <a:lnRef idx="1">
+            <a:schemeClr val="accent1"/>
+          </a:lnRef>
+          <a:fillRef idx="3">
+            <a:schemeClr val="accent1"/>
+          </a:fillRef>
+          <a:effectRef idx="2">
+            <a:schemeClr val="accent1"/>
+          </a:effectRef>
+          <a:fontRef idx="minor">
+            <a:schemeClr val="lt1"/>
+          </a:fontRef>
+        </p:style>
+        <p:txBody>
+          <a:bodyPr rtlCol="0" anchor="ctr"/>
+          <a:lstStyle/>
+          <a:p>
+            <a:pPr algn="ctr"/>
+          </a:p>
+        </p:txBody>
+      </p:sp>
+      <p:pic>
+        <p:nvPicPr>
+          <p:cNvPr id="3" name="Picture 2" descr="No4_ER_Vent_Fan_Power_Path_From_Start.png"/>
+          <p:cNvPicPr>
+            <a:picLocks noChangeAspect="1"/>
+          </p:cNvPicPr>
+          <p:nvPr/>
+        </p:nvPicPr>
+        <p:blipFill>
+          <a:blip r:embed="rId2"/>
+          <a:stretch>
+            <a:fillRect/>
+          </a:stretch>
+        </p:blipFill>
+        <p:spPr>
+          <a:xfrm>
+            <a:off x="137160" y="91440"/>
+            <a:ext cx="11887200" cy="7132320"/>
+          </a:xfrm>
+          <a:prstGeom prst="rect">
+            <a:avLst/>
+          </a:prstGeom>
+        </p:spPr>
+      </p:pic>
+    </p:spTree>
+  </p:cSld>
+  <p:clrMapOvr>
+    <a:masterClrMapping/>
+  </p:clrMapOvr>
+</p:sld>
+</file>
+
+<file path=ppt/slides/slide13.xml><?xml version="1.0" encoding="utf-8"?>
+<p:sld xmlns:a="http://schemas.openxmlformats.org/drawingml/2006/main" xmlns:p="http://schemas.openxmlformats.org/presentationml/2006/main" xmlns:r="http://schemas.openxmlformats.org/officeDocument/2006/relationships">
+  <p:cSld>
+    <p:spTree>
+      <p:nvGrpSpPr>
+        <p:cNvPr id="1" name=""/>
+        <p:cNvGrpSpPr/>
+        <p:nvPr/>
+      </p:nvGrpSpPr>
+      <p:grpSpPr/>
+      <p:sp>
+        <p:nvSpPr>
+          <p:cNvPr id="2" name="Rectangle 1"/>
+          <p:cNvSpPr/>
+          <p:nvPr/>
+        </p:nvSpPr>
+        <p:spPr>
+          <a:xfrm>
+            <a:off x="0" y="0"/>
+            <a:ext cx="12191695" cy="6858000"/>
+          </a:xfrm>
+          <a:prstGeom prst="rect">
+            <a:avLst/>
+          </a:prstGeom>
+          <a:solidFill>
+            <a:srgbClr val="F4F7FA"/>
+          </a:solidFill>
+          <a:ln>
+            <a:noFill/>
+          </a:ln>
+        </p:spPr>
+        <p:style>
+          <a:lnRef idx="1">
+            <a:schemeClr val="accent1"/>
+          </a:lnRef>
+          <a:fillRef idx="3">
+            <a:schemeClr val="accent1"/>
+          </a:fillRef>
+          <a:effectRef idx="2">
+            <a:schemeClr val="accent1"/>
+          </a:effectRef>
+          <a:fontRef idx="minor">
+            <a:schemeClr val="lt1"/>
+          </a:fontRef>
+        </p:style>
+        <p:txBody>
+          <a:bodyPr rtlCol="0" anchor="ctr"/>
+          <a:lstStyle/>
+          <a:p>
+            <a:pPr algn="ctr"/>
+          </a:p>
+        </p:txBody>
+      </p:sp>
+      <p:pic>
+        <p:nvPicPr>
+          <p:cNvPr id="3" name="Picture 2" descr="No4_ER_Vent_Fan_Control_Path_From_Start.png"/>
+          <p:cNvPicPr>
+            <a:picLocks noChangeAspect="1"/>
+          </p:cNvPicPr>
+          <p:nvPr/>
+        </p:nvPicPr>
+        <p:blipFill>
+          <a:blip r:embed="rId2"/>
+          <a:stretch>
+            <a:fillRect/>
+          </a:stretch>
+        </p:blipFill>
+        <p:spPr>
+          <a:xfrm>
+            <a:off x="137160" y="91440"/>
+            <a:ext cx="11887200" cy="7132320"/>
+          </a:xfrm>
+          <a:prstGeom prst="rect">
+            <a:avLst/>
+          </a:prstGeom>
+        </p:spPr>
+      </p:pic>
     </p:spTree>
   </p:cSld>
   <p:clrMapOvr>

</xml_diff>